<commit_message>
feat: render microsoft-autopilot-agents revision 05 with four voices
- master all variants to -16 LUFS on the latest Remotion adapter
- refresh analysis across all revisions and native Office QA

🎙️ - Generated by Copilot

Co-authored-by: Copilot <223556219+Copilot@users.noreply.github.com>
</commit_message>
<xml_diff>
--- a/projects/microsoft-autopilot-agents/release/outputs/deck.pptx
+++ b/projects/microsoft-autopilot-agents/release/outputs/deck.pptx
@@ -925,7 +925,7 @@
         <p:spPr>
           <a:xfrm>
             <a:off x="685800" y="3000000"/>
-            <a:ext cx="9600000" cy="1200000"/>
+            <a:ext cx="9600000" cy="1400000"/>
           </a:xfrm>
           <a:prstGeom prst="rect">
             <a:avLst/>
@@ -950,7 +950,7 @@
               </a:spcAft>
             </a:pPr>
             <a:r>
-              <a:rPr lang="en-US" sz="1700">
+              <a:rPr lang="en-US" sz="1800">
                 <a:solidFill>
                   <a:srgbClr val="B2BCC4"/>
                 </a:solidFill>
@@ -1057,7 +1057,7 @@
                   <a:srgbClr val="B2BCC4"/>
                 </a:solidFill>
               </a:rPr>
-              <a:t>microsoft-autopilot-agents-r1</a:t>
+              <a:t>microsoft-autopilot-agents-2026-05-am-michael-kokoro-onnx</a:t>
             </a:r>
           </a:p>
         </p:txBody>
@@ -1333,7 +1333,7 @@
                   <a:srgbClr val="B2BCC4"/>
                 </a:solidFill>
               </a:rPr>
-              <a:t>Sources: [ev-01] Introducing the new Copilot with Home, Code and Autopilot  ·  [ev-02] Introducing the new Copilot with Home, Code and Autopilot  ·  [ev-03] Introducing the new Copilot with Home, Code and Autopilot</a:t>
+              <a:t>Sources: Introducing the new Copilot with Home, Code and Autopilot</a:t>
             </a:r>
           </a:p>
         </p:txBody>
@@ -1609,7 +1609,7 @@
                   <a:srgbClr val="B2BCC4"/>
                 </a:solidFill>
               </a:rPr>
-              <a:t>Sources: [ev-05] What is an autopilot in Microsoft Foundry?  ·  [ev-06] What is an autopilot in Microsoft Foundry?  ·  [ev-07] What is an autopilot in Microsoft Foundry?</a:t>
+              <a:t>Sources: What is an autopilot in Microsoft Foundry?</a:t>
             </a:r>
           </a:p>
         </p:txBody>
@@ -1885,7 +1885,7 @@
                   <a:srgbClr val="B2BCC4"/>
                 </a:solidFill>
               </a:rPr>
-              <a:t>Sources: [ev-04] Introducing the new Copilot with Home, Code and Autopilot  ·  [ev-08] What is an autopilot in Microsoft Foundry?  ·  [ev-09] What is an autopilot in Microsoft Foundry?</a:t>
+              <a:t>Sources: Introducing the new Copilot with Home, Code and Autopilot  ·  What is an autopilot in Microsoft Foundry?</a:t>
             </a:r>
           </a:p>
         </p:txBody>
@@ -2061,7 +2061,7 @@
               </a:spcAft>
             </a:pPr>
             <a:r>
-              <a:rPr lang="en-US" sz="1800" b="1">
+              <a:rPr lang="en-US" sz="1400" b="1">
                 <a:solidFill>
                   <a:srgbClr val="F4FBFF"/>
                 </a:solidFill>
@@ -2069,7 +2069,7 @@
               <a:t>Introducing the new Copilot with Home, Code and Autopilot</a:t>
             </a:r>
             <a:r>
-              <a:rPr lang="en-US" sz="1200">
+              <a:rPr lang="en-US" sz="1100">
                 <a:solidFill>
                   <a:srgbClr val="B2BCC4"/>
                 </a:solidFill>
@@ -2083,11 +2083,11 @@
                 <a:spcPct val="105000"/>
               </a:lnSpc>
               <a:spcAft>
-                <a:spcPts val="1400"/>
+                <a:spcPts val="900"/>
               </a:spcAft>
             </a:pPr>
             <a:r>
-              <a:rPr lang="en-US" sz="1400">
+              <a:rPr lang="en-US" sz="1100">
                 <a:solidFill>
                   <a:srgbClr val="16B8C8"/>
                 </a:solidFill>
@@ -2105,7 +2105,7 @@
               </a:spcAft>
             </a:pPr>
             <a:r>
-              <a:rPr lang="en-US" sz="1800" b="1">
+              <a:rPr lang="en-US" sz="1400" b="1">
                 <a:solidFill>
                   <a:srgbClr val="F4FBFF"/>
                 </a:solidFill>
@@ -2113,7 +2113,7 @@
               <a:t>What is an autopilot in Microsoft Foundry?</a:t>
             </a:r>
             <a:r>
-              <a:rPr lang="en-US" sz="1200">
+              <a:rPr lang="en-US" sz="1100">
                 <a:solidFill>
                   <a:srgbClr val="B2BCC4"/>
                 </a:solidFill>
@@ -2127,11 +2127,11 @@
                 <a:spcPct val="105000"/>
               </a:lnSpc>
               <a:spcAft>
-                <a:spcPts val="1400"/>
+                <a:spcPts val="900"/>
               </a:spcAft>
             </a:pPr>
             <a:r>
-              <a:rPr lang="en-US" sz="1400">
+              <a:rPr lang="en-US" sz="1100">
                 <a:solidFill>
                   <a:srgbClr val="16B8C8"/>
                 </a:solidFill>
@@ -2180,7 +2180,7 @@
                   <a:srgbClr val="B2BCC4"/>
                 </a:solidFill>
               </a:rPr>
-              <a:t>microsoft-autopilot-agents-r1</a:t>
+              <a:t>microsoft-autopilot-agents-2026-05-am-michael-kokoro-onnx</a:t>
             </a:r>
           </a:p>
         </p:txBody>

</xml_diff>

<commit_message>
feat: regenerate microsoft-autopilot-agents with LF-stable release generation
- render four voices so release-verify passes on any checkout

🎙️ - Generated by Copilot

Co-authored-by: Copilot <223556219+Copilot@users.noreply.github.com>
</commit_message>
<xml_diff>
--- a/projects/microsoft-autopilot-agents/release/outputs/deck.pptx
+++ b/projects/microsoft-autopilot-agents/release/outputs/deck.pptx
@@ -1057,7 +1057,7 @@
                   <a:srgbClr val="B2BCC4"/>
                 </a:solidFill>
               </a:rPr>
-              <a:t>microsoft-autopilot-agents-2026-05-am-michael-kokoro-onnx</a:t>
+              <a:t>microsoft-autopilot-agents-2026-06-am-michael-kokoro-onnx</a:t>
             </a:r>
           </a:p>
         </p:txBody>
@@ -2180,7 +2180,7 @@
                   <a:srgbClr val="B2BCC4"/>
                 </a:solidFill>
               </a:rPr>
-              <a:t>microsoft-autopilot-agents-2026-05-am-michael-kokoro-onnx</a:t>
+              <a:t>microsoft-autopilot-agents-2026-06-am-michael-kokoro-onnx</a:t>
             </a:r>
           </a:p>
         </p:txBody>

</xml_diff>

<commit_message>
feat: regenerate microsoft-autopilot-agents with its brand theme
- render four voices with the brand header band, palette and fonts

🎨 - Generated by Copilot

Co-authored-by: Copilot <223556219+Copilot@users.noreply.github.com>
</commit_message>
<xml_diff>
--- a/projects/microsoft-autopilot-agents/release/outputs/deck.pptx
+++ b/projects/microsoft-autopilot-agents/release/outputs/deck.pptx
@@ -17,6 +17,16 @@
     <a:defPPr>
       <a:defRPr lang="en-US"/>
     </a:defPPr>
+    <a:lvl1pPr algn="l" defTabSz="914400" marL="0" indent="0">
+      <a:defRPr sz="1800" kern="1200">
+        <a:solidFill>
+          <a:schemeClr val="tx1"/>
+        </a:solidFill>
+        <a:latin typeface="+mn-lt"/>
+        <a:ea typeface="+mn-ea"/>
+        <a:cs typeface="+mn-cs"/>
+      </a:defRPr>
+    </a:lvl1pPr>
   </p:defaultTextStyle>
 </p:presentation>
 </file>
@@ -830,7 +840,7 @@
     <p:bg>
       <p:bgPr>
         <a:solidFill>
-          <a:srgbClr val="071B2D"/>
+          <a:srgbClr val="F4F8FC"/>
         </a:solidFill>
         <a:effectLst/>
       </p:bgPr>
@@ -844,20 +854,20 @@
       <p:grpSpPr/>
       <p:sp>
         <p:nvSpPr>
-          <p:cNvPr id="2" name="Accent band"/>
+          <p:cNvPr id="2" name="Brand band"/>
           <p:cNvSpPr/>
           <p:nvPr/>
         </p:nvSpPr>
         <p:spPr>
           <a:xfrm>
             <a:off x="0" y="0"/>
-            <a:ext cx="12192000" cy="91440"/>
+            <a:ext cx="12192000" cy="502920"/>
           </a:xfrm>
           <a:prstGeom prst="rect">
             <a:avLst/>
           </a:prstGeom>
           <a:solidFill>
-            <a:srgbClr val="16B8C8"/>
+            <a:srgbClr val="0E1726"/>
           </a:solidFill>
           <a:ln>
             <a:noFill/>
@@ -866,14 +876,36 @@
       </p:sp>
       <p:sp>
         <p:nvSpPr>
-          <p:cNvPr id="3" name="Title"/>
-          <p:cNvSpPr txBox="1"/>
-          <p:nvPr/>
-        </p:nvSpPr>
-        <p:spPr>
-          <a:xfrm>
-            <a:off x="685800" y="900000"/>
-            <a:ext cx="10820400" cy="2000000"/>
+          <p:cNvPr id="3" name="Highlight rule"/>
+          <p:cNvSpPr/>
+          <p:nvPr/>
+        </p:nvSpPr>
+        <p:spPr>
+          <a:xfrm>
+            <a:off x="0" y="502920"/>
+            <a:ext cx="12192000" cy="45720"/>
+          </a:xfrm>
+          <a:prstGeom prst="rect">
+            <a:avLst/>
+          </a:prstGeom>
+          <a:solidFill>
+            <a:srgbClr val="8AC1EB"/>
+          </a:solidFill>
+          <a:ln>
+            <a:noFill/>
+          </a:ln>
+        </p:spPr>
+      </p:sp>
+      <p:sp>
+        <p:nvSpPr>
+          <p:cNvPr id="4" name="Deck kicker"/>
+          <p:cNvSpPr txBox="1"/>
+          <p:nvPr/>
+        </p:nvSpPr>
+        <p:spPr>
+          <a:xfrm>
+            <a:off x="685800" y="0"/>
+            <a:ext cx="8400000" cy="502920"/>
           </a:xfrm>
           <a:prstGeom prst="rect">
             <a:avLst/>
@@ -898,45 +930,74 @@
               </a:spcAft>
             </a:pPr>
             <a:r>
-              <a:rPr lang="en-US" sz="3600" b="1">
-                <a:solidFill>
-                  <a:srgbClr val="F4FBFF"/>
-                </a:solidFill>
-              </a:rPr>
-              <a:t>Autopilot Agents:</a:t>
-            </a:r>
-            <a:r>
-              <a:rPr lang="en-US" sz="3600" b="1">
-                <a:solidFill>
-                  <a:srgbClr val="16B8C8"/>
-                </a:solidFill>
-              </a:rPr>
-              <a:t> decide the operating model before the rollout</a:t>
-            </a:r>
-          </a:p>
-        </p:txBody>
-      </p:sp>
-      <p:sp>
-        <p:nvSpPr>
-          <p:cNvPr id="4" name="Summary"/>
-          <p:cNvSpPr txBox="1"/>
-          <p:nvPr/>
-        </p:nvSpPr>
-        <p:spPr>
-          <a:xfrm>
-            <a:off x="685800" y="3000000"/>
-            <a:ext cx="9600000" cy="1400000"/>
-          </a:xfrm>
-          <a:prstGeom prst="rect">
-            <a:avLst/>
-          </a:prstGeom>
-          <a:noFill/>
-          <a:ln>
-            <a:noFill/>
-          </a:ln>
-        </p:spPr>
-        <p:txBody>
-          <a:bodyPr wrap="square" lIns="182880" tIns="91440" rIns="182880" bIns="91440" anchor="t">
+              <a:rPr lang="en-US" sz="1100" b="1" cap="all" spc="120">
+                <a:solidFill>
+                  <a:srgbClr val="FFFFFF"/>
+                </a:solidFill>
+              </a:rPr>
+              <a:t>Autopilot Agents</a:t>
+            </a:r>
+          </a:p>
+        </p:txBody>
+      </p:sp>
+      <p:sp>
+        <p:nvSpPr>
+          <p:cNvPr id="5" name="Slide number"/>
+          <p:cNvSpPr txBox="1"/>
+          <p:nvPr/>
+        </p:nvSpPr>
+        <p:spPr>
+          <a:xfrm>
+            <a:off x="9100000" y="0"/>
+            <a:ext cx="2406400" cy="502920"/>
+          </a:xfrm>
+          <a:prstGeom prst="rect">
+            <a:avLst/>
+          </a:prstGeom>
+          <a:noFill/>
+          <a:ln>
+            <a:noFill/>
+          </a:ln>
+        </p:spPr>
+        <p:txBody>
+          <a:bodyPr wrap="square" lIns="182880" tIns="91440" rIns="182880" bIns="91440" anchor="ctr">
+            <a:normAutofit/>
+          </a:bodyPr>
+          <a:lstStyle/>
+          <a:p>
+            <a:pPr algn="r"/>
+            <a:r>
+              <a:rPr lang="en-US" sz="1100" b="1" cap="all" spc="120">
+                <a:solidFill>
+                  <a:srgbClr val="BCBEC2"/>
+                </a:solidFill>
+              </a:rPr>
+              <a:t>1 / 5</a:t>
+            </a:r>
+          </a:p>
+        </p:txBody>
+      </p:sp>
+      <p:sp>
+        <p:nvSpPr>
+          <p:cNvPr id="6" name="Title"/>
+          <p:cNvSpPr txBox="1"/>
+          <p:nvPr/>
+        </p:nvSpPr>
+        <p:spPr>
+          <a:xfrm>
+            <a:off x="685800" y="1100000"/>
+            <a:ext cx="10820400" cy="2000000"/>
+          </a:xfrm>
+          <a:prstGeom prst="rect">
+            <a:avLst/>
+          </a:prstGeom>
+          <a:noFill/>
+          <a:ln>
+            <a:noFill/>
+          </a:ln>
+        </p:spPr>
+        <p:txBody>
+          <a:bodyPr wrap="square" lIns="182880" tIns="91440" rIns="182880" bIns="91440" anchor="ctr">
             <a:normAutofit/>
           </a:bodyPr>
           <a:lstStyle/>
@@ -950,43 +1011,47 @@
               </a:spcAft>
             </a:pPr>
             <a:r>
-              <a:rPr lang="en-US" sz="1800">
-                <a:solidFill>
-                  <a:srgbClr val="B2BCC4"/>
-                </a:solidFill>
-              </a:rPr>
-              <a:t>Bottom line: Copilot Autopilot is a bounded standing role, not a chatbot. Pilot privately with one owner, scoped access, cost guardrail and review.</a:t>
-            </a:r>
-          </a:p>
-        </p:txBody>
-      </p:sp>
-      <p:sp>
-        <p:nvSpPr>
-          <p:cNvPr id="5" name="Decision"/>
-          <p:cNvSpPr/>
-          <p:nvPr/>
-        </p:nvSpPr>
-        <p:spPr>
-          <a:xfrm>
-            <a:off x="685800" y="4500000"/>
-            <a:ext cx="10820400" cy="1000000"/>
-          </a:xfrm>
-          <a:prstGeom prst="roundRect">
-            <a:avLst>
-              <a:gd name="adj" fmla="val 9000"/>
-            </a:avLst>
-          </a:prstGeom>
-          <a:solidFill>
-            <a:srgbClr val="093446"/>
-          </a:solidFill>
-          <a:ln w="12700">
-            <a:solidFill>
-              <a:srgbClr val="16B8C8"/>
-            </a:solidFill>
-          </a:ln>
-        </p:spPr>
-        <p:txBody>
-          <a:bodyPr wrap="square" lIns="182880" tIns="91440" rIns="182880" bIns="91440" anchor="ctr">
+              <a:rPr lang="en-US" sz="3600" b="1">
+                <a:solidFill>
+                  <a:srgbClr val="0B121E"/>
+                </a:solidFill>
+                <a:latin typeface="+mj-lt"/>
+              </a:rPr>
+              <a:t>Autopilot Agents:</a:t>
+            </a:r>
+            <a:r>
+              <a:rPr lang="en-US" sz="3600" b="1">
+                <a:solidFill>
+                  <a:srgbClr val="006EC3"/>
+                </a:solidFill>
+                <a:latin typeface="+mj-lt"/>
+              </a:rPr>
+              <a:t> decide the operating model before the rollout</a:t>
+            </a:r>
+          </a:p>
+        </p:txBody>
+      </p:sp>
+      <p:sp>
+        <p:nvSpPr>
+          <p:cNvPr id="7" name="Summary"/>
+          <p:cNvSpPr txBox="1"/>
+          <p:nvPr/>
+        </p:nvSpPr>
+        <p:spPr>
+          <a:xfrm>
+            <a:off x="685800" y="3150000"/>
+            <a:ext cx="9600000" cy="1400000"/>
+          </a:xfrm>
+          <a:prstGeom prst="rect">
+            <a:avLst/>
+          </a:prstGeom>
+          <a:noFill/>
+          <a:ln>
+            <a:noFill/>
+          </a:ln>
+        </p:spPr>
+        <p:txBody>
+          <a:bodyPr wrap="square" lIns="182880" tIns="91440" rIns="182880" bIns="91440" anchor="t">
             <a:normAutofit/>
           </a:bodyPr>
           <a:lstStyle/>
@@ -1000,45 +1065,43 @@
               </a:spcAft>
             </a:pPr>
             <a:r>
-              <a:rPr lang="en-US" sz="1400" b="1">
-                <a:solidFill>
-                  <a:srgbClr val="16B8C8"/>
-                </a:solidFill>
-              </a:rPr>
-              <a:t>DECISION  </a:t>
-            </a:r>
-            <a:r>
-              <a:rPr lang="en-US" sz="1600" b="1">
-                <a:solidFill>
-                  <a:srgbClr val="F4FBFF"/>
-                </a:solidFill>
-              </a:rPr>
-              <a:t>Approve one narrow private-preview pilot only when a named business leader owns the goal, access boundary, cost guardrail, exception path and outcome review.</a:t>
-            </a:r>
-          </a:p>
-        </p:txBody>
-      </p:sp>
-      <p:sp>
-        <p:nvSpPr>
-          <p:cNvPr id="6" name="Footer"/>
-          <p:cNvSpPr txBox="1"/>
-          <p:nvPr/>
-        </p:nvSpPr>
-        <p:spPr>
-          <a:xfrm>
-            <a:off x="685800" y="6250000"/>
-            <a:ext cx="9400000" cy="420000"/>
-          </a:xfrm>
-          <a:prstGeom prst="rect">
-            <a:avLst/>
-          </a:prstGeom>
-          <a:noFill/>
-          <a:ln>
-            <a:noFill/>
-          </a:ln>
-        </p:spPr>
-        <p:txBody>
-          <a:bodyPr wrap="square" lIns="182880" tIns="91440" rIns="182880" bIns="91440" anchor="t">
+              <a:rPr lang="en-US" sz="1800">
+                <a:solidFill>
+                  <a:srgbClr val="64686E"/>
+                </a:solidFill>
+              </a:rPr>
+              <a:t>Bottom line: Copilot Autopilot is a bounded standing role, not a chatbot. Pilot privately with one owner, scoped access, cost guardrail and review.</a:t>
+            </a:r>
+          </a:p>
+        </p:txBody>
+      </p:sp>
+      <p:sp>
+        <p:nvSpPr>
+          <p:cNvPr id="8" name="Decision"/>
+          <p:cNvSpPr/>
+          <p:nvPr/>
+        </p:nvSpPr>
+        <p:spPr>
+          <a:xfrm>
+            <a:off x="685800" y="4650000"/>
+            <a:ext cx="10820400" cy="1000000"/>
+          </a:xfrm>
+          <a:prstGeom prst="roundRect">
+            <a:avLst>
+              <a:gd name="adj" fmla="val 6000"/>
+            </a:avLst>
+          </a:prstGeom>
+          <a:solidFill>
+            <a:srgbClr val="EDF6FC"/>
+          </a:solidFill>
+          <a:ln w="12700">
+            <a:solidFill>
+              <a:srgbClr val="567892"/>
+            </a:solidFill>
+          </a:ln>
+        </p:spPr>
+        <p:txBody>
+          <a:bodyPr wrap="square" lIns="182880" tIns="91440" rIns="182880" bIns="91440" anchor="ctr">
             <a:normAutofit/>
           </a:bodyPr>
           <a:lstStyle/>
@@ -1052,26 +1115,34 @@
               </a:spcAft>
             </a:pPr>
             <a:r>
-              <a:rPr lang="en-US" sz="1000">
-                <a:solidFill>
-                  <a:srgbClr val="B2BCC4"/>
-                </a:solidFill>
-              </a:rPr>
-              <a:t>microsoft-autopilot-agents-2026-06-am-michael-kokoro-onnx</a:t>
-            </a:r>
-          </a:p>
-        </p:txBody>
-      </p:sp>
-      <p:sp>
-        <p:nvSpPr>
-          <p:cNvPr id="7" name="Slide number"/>
-          <p:cNvSpPr txBox="1"/>
-          <p:nvPr/>
-        </p:nvSpPr>
-        <p:spPr>
-          <a:xfrm>
-            <a:off x="10100000" y="6250000"/>
-            <a:ext cx="1400000" cy="420000"/>
+              <a:rPr lang="en-US" sz="1400" b="1">
+                <a:solidFill>
+                  <a:srgbClr val="006EC3"/>
+                </a:solidFill>
+              </a:rPr>
+              <a:t>DECISION  </a:t>
+            </a:r>
+            <a:r>
+              <a:rPr lang="en-US" sz="1600" b="1">
+                <a:solidFill>
+                  <a:srgbClr val="0B121E"/>
+                </a:solidFill>
+              </a:rPr>
+              <a:t>Approve one narrow private-preview pilot only when a named business leader owns the goal, access boundary, cost guardrail, exception path and outcome review.</a:t>
+            </a:r>
+          </a:p>
+        </p:txBody>
+      </p:sp>
+      <p:sp>
+        <p:nvSpPr>
+          <p:cNvPr id="9" name="Footer"/>
+          <p:cNvSpPr txBox="1"/>
+          <p:nvPr/>
+        </p:nvSpPr>
+        <p:spPr>
+          <a:xfrm>
+            <a:off x="685800" y="6250000"/>
+            <a:ext cx="10820400" cy="420000"/>
           </a:xfrm>
           <a:prstGeom prst="rect">
             <a:avLst/>
@@ -1087,14 +1158,21 @@
           </a:bodyPr>
           <a:lstStyle/>
           <a:p>
-            <a:pPr algn="r"/>
+            <a:pPr algn="l">
+              <a:lnSpc>
+                <a:spcPct val="105000"/>
+              </a:lnSpc>
+              <a:spcAft>
+                <a:spcPts val="0"/>
+              </a:spcAft>
+            </a:pPr>
             <a:r>
               <a:rPr lang="en-US" sz="1000">
                 <a:solidFill>
-                  <a:srgbClr val="B2BCC4"/>
-                </a:solidFill>
-              </a:rPr>
-              <a:t>1 / 5</a:t>
+                  <a:srgbClr val="64686E"/>
+                </a:solidFill>
+              </a:rPr>
+              <a:t>microsoft-autopilot-agents-2026-07-am-michael-kokoro-onnx</a:t>
             </a:r>
           </a:p>
         </p:txBody>
@@ -1113,7 +1191,7 @@
     <p:bg>
       <p:bgPr>
         <a:solidFill>
-          <a:srgbClr val="071B2D"/>
+          <a:srgbClr val="F4F8FC"/>
         </a:solidFill>
         <a:effectLst/>
       </p:bgPr>
@@ -1127,20 +1205,20 @@
       <p:grpSpPr/>
       <p:sp>
         <p:nvSpPr>
-          <p:cNvPr id="2" name="Accent band"/>
+          <p:cNvPr id="2" name="Brand band"/>
           <p:cNvSpPr/>
           <p:nvPr/>
         </p:nvSpPr>
         <p:spPr>
           <a:xfrm>
             <a:off x="0" y="0"/>
-            <a:ext cx="12192000" cy="91440"/>
+            <a:ext cx="12192000" cy="502920"/>
           </a:xfrm>
           <a:prstGeom prst="rect">
             <a:avLst/>
           </a:prstGeom>
           <a:solidFill>
-            <a:srgbClr val="16B8C8"/>
+            <a:srgbClr val="0E1726"/>
           </a:solidFill>
           <a:ln>
             <a:noFill/>
@@ -1149,14 +1227,36 @@
       </p:sp>
       <p:sp>
         <p:nvSpPr>
-          <p:cNvPr id="3" name="Title"/>
-          <p:cNvSpPr txBox="1"/>
-          <p:nvPr/>
-        </p:nvSpPr>
-        <p:spPr>
-          <a:xfrm>
-            <a:off x="685800" y="420000"/>
-            <a:ext cx="10820400" cy="1150000"/>
+          <p:cNvPr id="3" name="Highlight rule"/>
+          <p:cNvSpPr/>
+          <p:nvPr/>
+        </p:nvSpPr>
+        <p:spPr>
+          <a:xfrm>
+            <a:off x="0" y="502920"/>
+            <a:ext cx="12192000" cy="45720"/>
+          </a:xfrm>
+          <a:prstGeom prst="rect">
+            <a:avLst/>
+          </a:prstGeom>
+          <a:solidFill>
+            <a:srgbClr val="8AC1EB"/>
+          </a:solidFill>
+          <a:ln>
+            <a:noFill/>
+          </a:ln>
+        </p:spPr>
+      </p:sp>
+      <p:sp>
+        <p:nvSpPr>
+          <p:cNvPr id="4" name="Deck kicker"/>
+          <p:cNvSpPr txBox="1"/>
+          <p:nvPr/>
+        </p:nvSpPr>
+        <p:spPr>
+          <a:xfrm>
+            <a:off x="685800" y="0"/>
+            <a:ext cx="8400000" cy="502920"/>
           </a:xfrm>
           <a:prstGeom prst="rect">
             <a:avLst/>
@@ -1181,45 +1281,74 @@
               </a:spcAft>
             </a:pPr>
             <a:r>
-              <a:rPr lang="en-US" sz="2900" b="1">
-                <a:solidFill>
-                  <a:srgbClr val="F4FBFF"/>
-                </a:solidFill>
-              </a:rPr>
-              <a:t>1.</a:t>
-            </a:r>
-            <a:r>
-              <a:rPr lang="en-US" sz="2900" b="1">
-                <a:solidFill>
-                  <a:srgbClr val="16B8C8"/>
-                </a:solidFill>
-              </a:rPr>
-              <a:t> Change the unit of delegation</a:t>
-            </a:r>
-          </a:p>
-        </p:txBody>
-      </p:sp>
-      <p:sp>
-        <p:nvSpPr>
-          <p:cNvPr id="4" name="Body"/>
-          <p:cNvSpPr txBox="1"/>
-          <p:nvPr/>
-        </p:nvSpPr>
-        <p:spPr>
-          <a:xfrm>
-            <a:off x="685800" y="1750000"/>
-            <a:ext cx="3900000" cy="3900000"/>
-          </a:xfrm>
-          <a:prstGeom prst="rect">
-            <a:avLst/>
-          </a:prstGeom>
-          <a:noFill/>
-          <a:ln>
-            <a:noFill/>
-          </a:ln>
-        </p:spPr>
-        <p:txBody>
-          <a:bodyPr wrap="square" lIns="182880" tIns="91440" rIns="182880" bIns="91440" anchor="t">
+              <a:rPr lang="en-US" sz="1100" b="1" cap="all" spc="120">
+                <a:solidFill>
+                  <a:srgbClr val="FFFFFF"/>
+                </a:solidFill>
+              </a:rPr>
+              <a:t>Autopilot Agents</a:t>
+            </a:r>
+          </a:p>
+        </p:txBody>
+      </p:sp>
+      <p:sp>
+        <p:nvSpPr>
+          <p:cNvPr id="5" name="Slide number"/>
+          <p:cNvSpPr txBox="1"/>
+          <p:nvPr/>
+        </p:nvSpPr>
+        <p:spPr>
+          <a:xfrm>
+            <a:off x="9100000" y="0"/>
+            <a:ext cx="2406400" cy="502920"/>
+          </a:xfrm>
+          <a:prstGeom prst="rect">
+            <a:avLst/>
+          </a:prstGeom>
+          <a:noFill/>
+          <a:ln>
+            <a:noFill/>
+          </a:ln>
+        </p:spPr>
+        <p:txBody>
+          <a:bodyPr wrap="square" lIns="182880" tIns="91440" rIns="182880" bIns="91440" anchor="ctr">
+            <a:normAutofit/>
+          </a:bodyPr>
+          <a:lstStyle/>
+          <a:p>
+            <a:pPr algn="r"/>
+            <a:r>
+              <a:rPr lang="en-US" sz="1100" b="1" cap="all" spc="120">
+                <a:solidFill>
+                  <a:srgbClr val="BCBEC2"/>
+                </a:solidFill>
+              </a:rPr>
+              <a:t>2 / 5</a:t>
+            </a:r>
+          </a:p>
+        </p:txBody>
+      </p:sp>
+      <p:sp>
+        <p:nvSpPr>
+          <p:cNvPr id="6" name="Title"/>
+          <p:cNvSpPr txBox="1"/>
+          <p:nvPr/>
+        </p:nvSpPr>
+        <p:spPr>
+          <a:xfrm>
+            <a:off x="685800" y="700000"/>
+            <a:ext cx="10820400" cy="1150000"/>
+          </a:xfrm>
+          <a:prstGeom prst="rect">
+            <a:avLst/>
+          </a:prstGeom>
+          <a:noFill/>
+          <a:ln>
+            <a:noFill/>
+          </a:ln>
+        </p:spPr>
+        <p:txBody>
+          <a:bodyPr wrap="square" lIns="182880" tIns="91440" rIns="182880" bIns="91440" anchor="ctr">
             <a:normAutofit/>
           </a:bodyPr>
           <a:lstStyle/>
@@ -1233,77 +1362,36 @@
               </a:spcAft>
             </a:pPr>
             <a:r>
-              <a:rPr lang="en-US" sz="2100">
-                <a:solidFill>
-                  <a:srgbClr val="F4FBFF"/>
-                </a:solidFill>
-              </a:rPr>
-              <a:t>The shift is from asking for an answer to assigning a standing role. Autopilot brings identity, memory and a workspace; leaders still own objectives and boundaries. Governance changes with the unit of delegation.</a:t>
-            </a:r>
-          </a:p>
-        </p:txBody>
-      </p:sp>
-      <p:sp>
-        <p:nvSpPr>
-          <p:cNvPr id="5" name="Accent rule"/>
-          <p:cNvSpPr/>
-          <p:nvPr/>
-        </p:nvSpPr>
-        <p:spPr>
-          <a:xfrm>
-            <a:off x="548640" y="1800000"/>
-            <a:ext cx="45720" cy="3800000"/>
-          </a:xfrm>
-          <a:prstGeom prst="rect">
-            <a:avLst/>
-          </a:prstGeom>
-          <a:solidFill>
-            <a:srgbClr val="16B8C8"/>
-          </a:solidFill>
-          <a:ln>
-            <a:noFill/>
-          </a:ln>
-        </p:spPr>
-      </p:sp>
-      <p:pic>
-        <p:nvPicPr>
-          <p:cNvPr id="6" name="Asset visual-operating-model" descr="The operating-model shift: from one request to a bounded standing role with human accountability. (mermaid diagram)"/>
-          <p:cNvPicPr>
-            <a:picLocks noChangeAspect="1"/>
-          </p:cNvPicPr>
-          <p:nvPr/>
-        </p:nvPicPr>
-        <p:blipFill>
-          <a:blip r:embed="rIdImage1"/>
-          <a:stretch>
-            <a:fillRect/>
-          </a:stretch>
-        </p:blipFill>
-        <p:spPr>
-          <a:xfrm>
-            <a:off x="5000000" y="2021875"/>
-            <a:ext cx="6500000" cy="3656250"/>
-          </a:xfrm>
-          <a:prstGeom prst="rect">
-            <a:avLst/>
-          </a:prstGeom>
-          <a:ln>
-            <a:solidFill>
-              <a:srgbClr val="D9D9D9"/>
-            </a:solidFill>
-          </a:ln>
-        </p:spPr>
-      </p:pic>
-      <p:sp>
-        <p:nvSpPr>
-          <p:cNvPr id="7" name="Footer"/>
-          <p:cNvSpPr txBox="1"/>
-          <p:nvPr/>
-        </p:nvSpPr>
-        <p:spPr>
-          <a:xfrm>
-            <a:off x="685800" y="6250000"/>
-            <a:ext cx="9400000" cy="420000"/>
+              <a:rPr lang="en-US" sz="2900" b="1">
+                <a:solidFill>
+                  <a:srgbClr val="0B121E"/>
+                </a:solidFill>
+                <a:latin typeface="+mj-lt"/>
+              </a:rPr>
+              <a:t>1.</a:t>
+            </a:r>
+            <a:r>
+              <a:rPr lang="en-US" sz="2900" b="1">
+                <a:solidFill>
+                  <a:srgbClr val="006EC3"/>
+                </a:solidFill>
+                <a:latin typeface="+mj-lt"/>
+              </a:rPr>
+              <a:t> Change the unit of delegation</a:t>
+            </a:r>
+          </a:p>
+        </p:txBody>
+      </p:sp>
+      <p:sp>
+        <p:nvSpPr>
+          <p:cNvPr id="7" name="Body"/>
+          <p:cNvSpPr txBox="1"/>
+          <p:nvPr/>
+        </p:nvSpPr>
+        <p:spPr>
+          <a:xfrm>
+            <a:off x="685800" y="1950000"/>
+            <a:ext cx="3900000" cy="3900000"/>
           </a:xfrm>
           <a:prstGeom prst="rect">
             <a:avLst/>
@@ -1328,26 +1416,77 @@
               </a:spcAft>
             </a:pPr>
             <a:r>
-              <a:rPr lang="en-US" sz="1000">
-                <a:solidFill>
-                  <a:srgbClr val="B2BCC4"/>
-                </a:solidFill>
-              </a:rPr>
-              <a:t>Sources: Introducing the new Copilot with Home, Code and Autopilot</a:t>
-            </a:r>
-          </a:p>
-        </p:txBody>
-      </p:sp>
-      <p:sp>
-        <p:nvSpPr>
-          <p:cNvPr id="8" name="Slide number"/>
-          <p:cNvSpPr txBox="1"/>
-          <p:nvPr/>
-        </p:nvSpPr>
-        <p:spPr>
-          <a:xfrm>
-            <a:off x="10100000" y="6250000"/>
-            <a:ext cx="1400000" cy="420000"/>
+              <a:rPr lang="en-US" sz="2100">
+                <a:solidFill>
+                  <a:srgbClr val="0B121E"/>
+                </a:solidFill>
+              </a:rPr>
+              <a:t>The shift is from asking for an answer to assigning a standing role. Autopilot brings identity, memory and a workspace; leaders still own objectives and boundaries. Governance changes with the unit of delegation.</a:t>
+            </a:r>
+          </a:p>
+        </p:txBody>
+      </p:sp>
+      <p:sp>
+        <p:nvSpPr>
+          <p:cNvPr id="8" name="Accent rule"/>
+          <p:cNvSpPr/>
+          <p:nvPr/>
+        </p:nvSpPr>
+        <p:spPr>
+          <a:xfrm>
+            <a:off x="548640" y="2000000"/>
+            <a:ext cx="45720" cy="3800000"/>
+          </a:xfrm>
+          <a:prstGeom prst="rect">
+            <a:avLst/>
+          </a:prstGeom>
+          <a:solidFill>
+            <a:srgbClr val="006EC3"/>
+          </a:solidFill>
+          <a:ln>
+            <a:noFill/>
+          </a:ln>
+        </p:spPr>
+      </p:sp>
+      <p:pic>
+        <p:nvPicPr>
+          <p:cNvPr id="9" name="Asset visual-operating-model" descr="The operating-model shift: from one request to a bounded standing role with human accountability. (mermaid diagram)"/>
+          <p:cNvPicPr>
+            <a:picLocks noChangeAspect="1"/>
+          </p:cNvPicPr>
+          <p:nvPr/>
+        </p:nvPicPr>
+        <p:blipFill>
+          <a:blip r:embed="rIdImage1"/>
+          <a:stretch>
+            <a:fillRect/>
+          </a:stretch>
+        </p:blipFill>
+        <p:spPr>
+          <a:xfrm>
+            <a:off x="5000000" y="2221875"/>
+            <a:ext cx="6500000" cy="3656250"/>
+          </a:xfrm>
+          <a:prstGeom prst="rect">
+            <a:avLst/>
+          </a:prstGeom>
+          <a:ln>
+            <a:solidFill>
+              <a:srgbClr val="D9D9D9"/>
+            </a:solidFill>
+          </a:ln>
+        </p:spPr>
+      </p:pic>
+      <p:sp>
+        <p:nvSpPr>
+          <p:cNvPr id="10" name="Footer"/>
+          <p:cNvSpPr txBox="1"/>
+          <p:nvPr/>
+        </p:nvSpPr>
+        <p:spPr>
+          <a:xfrm>
+            <a:off x="685800" y="6250000"/>
+            <a:ext cx="10820400" cy="420000"/>
           </a:xfrm>
           <a:prstGeom prst="rect">
             <a:avLst/>
@@ -1363,14 +1502,21 @@
           </a:bodyPr>
           <a:lstStyle/>
           <a:p>
-            <a:pPr algn="r"/>
+            <a:pPr algn="l">
+              <a:lnSpc>
+                <a:spcPct val="105000"/>
+              </a:lnSpc>
+              <a:spcAft>
+                <a:spcPts val="0"/>
+              </a:spcAft>
+            </a:pPr>
             <a:r>
               <a:rPr lang="en-US" sz="1000">
                 <a:solidFill>
-                  <a:srgbClr val="B2BCC4"/>
-                </a:solidFill>
-              </a:rPr>
-              <a:t>2 / 5</a:t>
+                  <a:srgbClr val="64686E"/>
+                </a:solidFill>
+              </a:rPr>
+              <a:t>Sources: Introducing the new Copilot with Home, Code and Autopilot</a:t>
             </a:r>
           </a:p>
         </p:txBody>
@@ -1389,7 +1535,7 @@
     <p:bg>
       <p:bgPr>
         <a:solidFill>
-          <a:srgbClr val="071B2D"/>
+          <a:srgbClr val="F4F8FC"/>
         </a:solidFill>
         <a:effectLst/>
       </p:bgPr>
@@ -1403,20 +1549,20 @@
       <p:grpSpPr/>
       <p:sp>
         <p:nvSpPr>
-          <p:cNvPr id="2" name="Accent band"/>
+          <p:cNvPr id="2" name="Brand band"/>
           <p:cNvSpPr/>
           <p:nvPr/>
         </p:nvSpPr>
         <p:spPr>
           <a:xfrm>
             <a:off x="0" y="0"/>
-            <a:ext cx="12192000" cy="91440"/>
+            <a:ext cx="12192000" cy="502920"/>
           </a:xfrm>
           <a:prstGeom prst="rect">
             <a:avLst/>
           </a:prstGeom>
           <a:solidFill>
-            <a:srgbClr val="16B8C8"/>
+            <a:srgbClr val="0E1726"/>
           </a:solidFill>
           <a:ln>
             <a:noFill/>
@@ -1425,14 +1571,36 @@
       </p:sp>
       <p:sp>
         <p:nvSpPr>
-          <p:cNvPr id="3" name="Title"/>
-          <p:cNvSpPr txBox="1"/>
-          <p:nvPr/>
-        </p:nvSpPr>
-        <p:spPr>
-          <a:xfrm>
-            <a:off x="685800" y="420000"/>
-            <a:ext cx="10820400" cy="1150000"/>
+          <p:cNvPr id="3" name="Highlight rule"/>
+          <p:cNvSpPr/>
+          <p:nvPr/>
+        </p:nvSpPr>
+        <p:spPr>
+          <a:xfrm>
+            <a:off x="0" y="502920"/>
+            <a:ext cx="12192000" cy="45720"/>
+          </a:xfrm>
+          <a:prstGeom prst="rect">
+            <a:avLst/>
+          </a:prstGeom>
+          <a:solidFill>
+            <a:srgbClr val="8AC1EB"/>
+          </a:solidFill>
+          <a:ln>
+            <a:noFill/>
+          </a:ln>
+        </p:spPr>
+      </p:sp>
+      <p:sp>
+        <p:nvSpPr>
+          <p:cNvPr id="4" name="Deck kicker"/>
+          <p:cNvSpPr txBox="1"/>
+          <p:nvPr/>
+        </p:nvSpPr>
+        <p:spPr>
+          <a:xfrm>
+            <a:off x="685800" y="0"/>
+            <a:ext cx="8400000" cy="502920"/>
           </a:xfrm>
           <a:prstGeom prst="rect">
             <a:avLst/>
@@ -1457,45 +1625,74 @@
               </a:spcAft>
             </a:pPr>
             <a:r>
-              <a:rPr lang="en-US" sz="2900" b="1">
-                <a:solidFill>
-                  <a:srgbClr val="F4FBFF"/>
-                </a:solidFill>
-              </a:rPr>
-              <a:t>2.</a:t>
-            </a:r>
-            <a:r>
-              <a:rPr lang="en-US" sz="2900" b="1">
-                <a:solidFill>
-                  <a:srgbClr val="16B8C8"/>
-                </a:solidFill>
-              </a:rPr>
-              <a:t> Govern identity before capability</a:t>
-            </a:r>
-          </a:p>
-        </p:txBody>
-      </p:sp>
-      <p:sp>
-        <p:nvSpPr>
-          <p:cNvPr id="4" name="Body"/>
-          <p:cNvSpPr txBox="1"/>
-          <p:nvPr/>
-        </p:nvSpPr>
-        <p:spPr>
-          <a:xfrm>
-            <a:off x="685800" y="1750000"/>
-            <a:ext cx="3900000" cy="3900000"/>
-          </a:xfrm>
-          <a:prstGeom prst="rect">
-            <a:avLst/>
-          </a:prstGeom>
-          <a:noFill/>
-          <a:ln>
-            <a:noFill/>
-          </a:ln>
-        </p:spPr>
-        <p:txBody>
-          <a:bodyPr wrap="square" lIns="182880" tIns="91440" rIns="182880" bIns="91440" anchor="t">
+              <a:rPr lang="en-US" sz="1100" b="1" cap="all" spc="120">
+                <a:solidFill>
+                  <a:srgbClr val="FFFFFF"/>
+                </a:solidFill>
+              </a:rPr>
+              <a:t>Autopilot Agents</a:t>
+            </a:r>
+          </a:p>
+        </p:txBody>
+      </p:sp>
+      <p:sp>
+        <p:nvSpPr>
+          <p:cNvPr id="5" name="Slide number"/>
+          <p:cNvSpPr txBox="1"/>
+          <p:nvPr/>
+        </p:nvSpPr>
+        <p:spPr>
+          <a:xfrm>
+            <a:off x="9100000" y="0"/>
+            <a:ext cx="2406400" cy="502920"/>
+          </a:xfrm>
+          <a:prstGeom prst="rect">
+            <a:avLst/>
+          </a:prstGeom>
+          <a:noFill/>
+          <a:ln>
+            <a:noFill/>
+          </a:ln>
+        </p:spPr>
+        <p:txBody>
+          <a:bodyPr wrap="square" lIns="182880" tIns="91440" rIns="182880" bIns="91440" anchor="ctr">
+            <a:normAutofit/>
+          </a:bodyPr>
+          <a:lstStyle/>
+          <a:p>
+            <a:pPr algn="r"/>
+            <a:r>
+              <a:rPr lang="en-US" sz="1100" b="1" cap="all" spc="120">
+                <a:solidFill>
+                  <a:srgbClr val="BCBEC2"/>
+                </a:solidFill>
+              </a:rPr>
+              <a:t>3 / 5</a:t>
+            </a:r>
+          </a:p>
+        </p:txBody>
+      </p:sp>
+      <p:sp>
+        <p:nvSpPr>
+          <p:cNvPr id="6" name="Title"/>
+          <p:cNvSpPr txBox="1"/>
+          <p:nvPr/>
+        </p:nvSpPr>
+        <p:spPr>
+          <a:xfrm>
+            <a:off x="685800" y="700000"/>
+            <a:ext cx="10820400" cy="1150000"/>
+          </a:xfrm>
+          <a:prstGeom prst="rect">
+            <a:avLst/>
+          </a:prstGeom>
+          <a:noFill/>
+          <a:ln>
+            <a:noFill/>
+          </a:ln>
+        </p:spPr>
+        <p:txBody>
+          <a:bodyPr wrap="square" lIns="182880" tIns="91440" rIns="182880" bIns="91440" anchor="ctr">
             <a:normAutofit/>
           </a:bodyPr>
           <a:lstStyle/>
@@ -1509,77 +1706,36 @@
               </a:spcAft>
             </a:pPr>
             <a:r>
-              <a:rPr lang="en-US" sz="2100">
-                <a:solidFill>
-                  <a:srgbClr val="F4FBFF"/>
-                </a:solidFill>
-              </a:rPr>
-              <a:t>Foundry is an architectural lens, not proof of identical implementation. Identity anchors the standing role; the organization still bounds interactions, access and actions, with a manager accountable for the role.</a:t>
-            </a:r>
-          </a:p>
-        </p:txBody>
-      </p:sp>
-      <p:sp>
-        <p:nvSpPr>
-          <p:cNvPr id="5" name="Accent rule"/>
-          <p:cNvSpPr/>
-          <p:nvPr/>
-        </p:nvSpPr>
-        <p:spPr>
-          <a:xfrm>
-            <a:off x="548640" y="1800000"/>
-            <a:ext cx="45720" cy="3800000"/>
-          </a:xfrm>
-          <a:prstGeom prst="rect">
-            <a:avLst/>
-          </a:prstGeom>
-          <a:solidFill>
-            <a:srgbClr val="16B8C8"/>
-          </a:solidFill>
-          <a:ln>
-            <a:noFill/>
-          </a:ln>
-        </p:spPr>
-      </p:sp>
-      <p:pic>
-        <p:nvPicPr>
-          <p:cNvPr id="6" name="Asset visual-identity-boundaries" descr="Identity anchors the role; goals, access and actions remain bounded by the organization. (excalidraw diagram)"/>
-          <p:cNvPicPr>
-            <a:picLocks noChangeAspect="1"/>
-          </p:cNvPicPr>
-          <p:nvPr/>
-        </p:nvPicPr>
-        <p:blipFill>
-          <a:blip r:embed="rIdImage1"/>
-          <a:stretch>
-            <a:fillRect/>
-          </a:stretch>
-        </p:blipFill>
-        <p:spPr>
-          <a:xfrm>
-            <a:off x="5000000" y="2021875"/>
-            <a:ext cx="6500000" cy="3656250"/>
-          </a:xfrm>
-          <a:prstGeom prst="rect">
-            <a:avLst/>
-          </a:prstGeom>
-          <a:ln>
-            <a:solidFill>
-              <a:srgbClr val="D9D9D9"/>
-            </a:solidFill>
-          </a:ln>
-        </p:spPr>
-      </p:pic>
-      <p:sp>
-        <p:nvSpPr>
-          <p:cNvPr id="7" name="Footer"/>
-          <p:cNvSpPr txBox="1"/>
-          <p:nvPr/>
-        </p:nvSpPr>
-        <p:spPr>
-          <a:xfrm>
-            <a:off x="685800" y="6250000"/>
-            <a:ext cx="9400000" cy="420000"/>
+              <a:rPr lang="en-US" sz="2900" b="1">
+                <a:solidFill>
+                  <a:srgbClr val="0B121E"/>
+                </a:solidFill>
+                <a:latin typeface="+mj-lt"/>
+              </a:rPr>
+              <a:t>2.</a:t>
+            </a:r>
+            <a:r>
+              <a:rPr lang="en-US" sz="2900" b="1">
+                <a:solidFill>
+                  <a:srgbClr val="006EC3"/>
+                </a:solidFill>
+                <a:latin typeface="+mj-lt"/>
+              </a:rPr>
+              <a:t> Govern identity before capability</a:t>
+            </a:r>
+          </a:p>
+        </p:txBody>
+      </p:sp>
+      <p:sp>
+        <p:nvSpPr>
+          <p:cNvPr id="7" name="Body"/>
+          <p:cNvSpPr txBox="1"/>
+          <p:nvPr/>
+        </p:nvSpPr>
+        <p:spPr>
+          <a:xfrm>
+            <a:off x="685800" y="1950000"/>
+            <a:ext cx="3900000" cy="3900000"/>
           </a:xfrm>
           <a:prstGeom prst="rect">
             <a:avLst/>
@@ -1604,26 +1760,77 @@
               </a:spcAft>
             </a:pPr>
             <a:r>
-              <a:rPr lang="en-US" sz="1000">
-                <a:solidFill>
-                  <a:srgbClr val="B2BCC4"/>
-                </a:solidFill>
-              </a:rPr>
-              <a:t>Sources: What is an autopilot in Microsoft Foundry?</a:t>
-            </a:r>
-          </a:p>
-        </p:txBody>
-      </p:sp>
-      <p:sp>
-        <p:nvSpPr>
-          <p:cNvPr id="8" name="Slide number"/>
-          <p:cNvSpPr txBox="1"/>
-          <p:nvPr/>
-        </p:nvSpPr>
-        <p:spPr>
-          <a:xfrm>
-            <a:off x="10100000" y="6250000"/>
-            <a:ext cx="1400000" cy="420000"/>
+              <a:rPr lang="en-US" sz="2100">
+                <a:solidFill>
+                  <a:srgbClr val="0B121E"/>
+                </a:solidFill>
+              </a:rPr>
+              <a:t>Foundry is an architectural lens, not proof of identical implementation. Identity anchors the standing role; the organization still bounds interactions, access and actions, with a manager accountable for the role.</a:t>
+            </a:r>
+          </a:p>
+        </p:txBody>
+      </p:sp>
+      <p:sp>
+        <p:nvSpPr>
+          <p:cNvPr id="8" name="Accent rule"/>
+          <p:cNvSpPr/>
+          <p:nvPr/>
+        </p:nvSpPr>
+        <p:spPr>
+          <a:xfrm>
+            <a:off x="548640" y="2000000"/>
+            <a:ext cx="45720" cy="3800000"/>
+          </a:xfrm>
+          <a:prstGeom prst="rect">
+            <a:avLst/>
+          </a:prstGeom>
+          <a:solidFill>
+            <a:srgbClr val="006EC3"/>
+          </a:solidFill>
+          <a:ln>
+            <a:noFill/>
+          </a:ln>
+        </p:spPr>
+      </p:sp>
+      <p:pic>
+        <p:nvPicPr>
+          <p:cNvPr id="9" name="Asset visual-identity-boundaries" descr="Identity anchors the role; goals, access and actions remain bounded by the organization. (excalidraw diagram)"/>
+          <p:cNvPicPr>
+            <a:picLocks noChangeAspect="1"/>
+          </p:cNvPicPr>
+          <p:nvPr/>
+        </p:nvPicPr>
+        <p:blipFill>
+          <a:blip r:embed="rIdImage1"/>
+          <a:stretch>
+            <a:fillRect/>
+          </a:stretch>
+        </p:blipFill>
+        <p:spPr>
+          <a:xfrm>
+            <a:off x="5000000" y="2221875"/>
+            <a:ext cx="6500000" cy="3656250"/>
+          </a:xfrm>
+          <a:prstGeom prst="rect">
+            <a:avLst/>
+          </a:prstGeom>
+          <a:ln>
+            <a:solidFill>
+              <a:srgbClr val="D9D9D9"/>
+            </a:solidFill>
+          </a:ln>
+        </p:spPr>
+      </p:pic>
+      <p:sp>
+        <p:nvSpPr>
+          <p:cNvPr id="10" name="Footer"/>
+          <p:cNvSpPr txBox="1"/>
+          <p:nvPr/>
+        </p:nvSpPr>
+        <p:spPr>
+          <a:xfrm>
+            <a:off x="685800" y="6250000"/>
+            <a:ext cx="10820400" cy="420000"/>
           </a:xfrm>
           <a:prstGeom prst="rect">
             <a:avLst/>
@@ -1639,14 +1846,21 @@
           </a:bodyPr>
           <a:lstStyle/>
           <a:p>
-            <a:pPr algn="r"/>
+            <a:pPr algn="l">
+              <a:lnSpc>
+                <a:spcPct val="105000"/>
+              </a:lnSpc>
+              <a:spcAft>
+                <a:spcPts val="0"/>
+              </a:spcAft>
+            </a:pPr>
             <a:r>
               <a:rPr lang="en-US" sz="1000">
                 <a:solidFill>
-                  <a:srgbClr val="B2BCC4"/>
-                </a:solidFill>
-              </a:rPr>
-              <a:t>3 / 5</a:t>
+                  <a:srgbClr val="64686E"/>
+                </a:solidFill>
+              </a:rPr>
+              <a:t>Sources: What is an autopilot in Microsoft Foundry?</a:t>
             </a:r>
           </a:p>
         </p:txBody>
@@ -1665,7 +1879,7 @@
     <p:bg>
       <p:bgPr>
         <a:solidFill>
-          <a:srgbClr val="071B2D"/>
+          <a:srgbClr val="F4F8FC"/>
         </a:solidFill>
         <a:effectLst/>
       </p:bgPr>
@@ -1679,20 +1893,20 @@
       <p:grpSpPr/>
       <p:sp>
         <p:nvSpPr>
-          <p:cNvPr id="2" name="Accent band"/>
+          <p:cNvPr id="2" name="Brand band"/>
           <p:cNvSpPr/>
           <p:nvPr/>
         </p:nvSpPr>
         <p:spPr>
           <a:xfrm>
             <a:off x="0" y="0"/>
-            <a:ext cx="12192000" cy="91440"/>
+            <a:ext cx="12192000" cy="502920"/>
           </a:xfrm>
           <a:prstGeom prst="rect">
             <a:avLst/>
           </a:prstGeom>
           <a:solidFill>
-            <a:srgbClr val="16B8C8"/>
+            <a:srgbClr val="0E1726"/>
           </a:solidFill>
           <a:ln>
             <a:noFill/>
@@ -1701,14 +1915,36 @@
       </p:sp>
       <p:sp>
         <p:nvSpPr>
-          <p:cNvPr id="3" name="Title"/>
-          <p:cNvSpPr txBox="1"/>
-          <p:nvPr/>
-        </p:nvSpPr>
-        <p:spPr>
-          <a:xfrm>
-            <a:off x="685800" y="420000"/>
-            <a:ext cx="10820400" cy="1150000"/>
+          <p:cNvPr id="3" name="Highlight rule"/>
+          <p:cNvSpPr/>
+          <p:nvPr/>
+        </p:nvSpPr>
+        <p:spPr>
+          <a:xfrm>
+            <a:off x="0" y="502920"/>
+            <a:ext cx="12192000" cy="45720"/>
+          </a:xfrm>
+          <a:prstGeom prst="rect">
+            <a:avLst/>
+          </a:prstGeom>
+          <a:solidFill>
+            <a:srgbClr val="8AC1EB"/>
+          </a:solidFill>
+          <a:ln>
+            <a:noFill/>
+          </a:ln>
+        </p:spPr>
+      </p:sp>
+      <p:sp>
+        <p:nvSpPr>
+          <p:cNvPr id="4" name="Deck kicker"/>
+          <p:cNvSpPr txBox="1"/>
+          <p:nvPr/>
+        </p:nvSpPr>
+        <p:spPr>
+          <a:xfrm>
+            <a:off x="685800" y="0"/>
+            <a:ext cx="8400000" cy="502920"/>
           </a:xfrm>
           <a:prstGeom prst="rect">
             <a:avLst/>
@@ -1733,45 +1969,74 @@
               </a:spcAft>
             </a:pPr>
             <a:r>
-              <a:rPr lang="en-US" sz="2900" b="1">
-                <a:solidFill>
-                  <a:srgbClr val="F4FBFF"/>
-                </a:solidFill>
-              </a:rPr>
-              <a:t>3.</a:t>
-            </a:r>
-            <a:r>
-              <a:rPr lang="en-US" sz="2900" b="1">
-                <a:solidFill>
-                  <a:srgbClr val="16B8C8"/>
-                </a:solidFill>
-              </a:rPr>
-              <a:t> Pilot the role, not the technology</a:t>
-            </a:r>
-          </a:p>
-        </p:txBody>
-      </p:sp>
-      <p:sp>
-        <p:nvSpPr>
-          <p:cNvPr id="4" name="Body"/>
-          <p:cNvSpPr txBox="1"/>
-          <p:nvPr/>
-        </p:nvSpPr>
-        <p:spPr>
-          <a:xfrm>
-            <a:off x="685800" y="1750000"/>
-            <a:ext cx="3900000" cy="3900000"/>
-          </a:xfrm>
-          <a:prstGeom prst="rect">
-            <a:avLst/>
-          </a:prstGeom>
-          <a:noFill/>
-          <a:ln>
-            <a:noFill/>
-          </a:ln>
-        </p:spPr>
-        <p:txBody>
-          <a:bodyPr wrap="square" lIns="182880" tIns="91440" rIns="182880" bIns="91440" anchor="t">
+              <a:rPr lang="en-US" sz="1100" b="1" cap="all" spc="120">
+                <a:solidFill>
+                  <a:srgbClr val="FFFFFF"/>
+                </a:solidFill>
+              </a:rPr>
+              <a:t>Autopilot Agents</a:t>
+            </a:r>
+          </a:p>
+        </p:txBody>
+      </p:sp>
+      <p:sp>
+        <p:nvSpPr>
+          <p:cNvPr id="5" name="Slide number"/>
+          <p:cNvSpPr txBox="1"/>
+          <p:nvPr/>
+        </p:nvSpPr>
+        <p:spPr>
+          <a:xfrm>
+            <a:off x="9100000" y="0"/>
+            <a:ext cx="2406400" cy="502920"/>
+          </a:xfrm>
+          <a:prstGeom prst="rect">
+            <a:avLst/>
+          </a:prstGeom>
+          <a:noFill/>
+          <a:ln>
+            <a:noFill/>
+          </a:ln>
+        </p:spPr>
+        <p:txBody>
+          <a:bodyPr wrap="square" lIns="182880" tIns="91440" rIns="182880" bIns="91440" anchor="ctr">
+            <a:normAutofit/>
+          </a:bodyPr>
+          <a:lstStyle/>
+          <a:p>
+            <a:pPr algn="r"/>
+            <a:r>
+              <a:rPr lang="en-US" sz="1100" b="1" cap="all" spc="120">
+                <a:solidFill>
+                  <a:srgbClr val="BCBEC2"/>
+                </a:solidFill>
+              </a:rPr>
+              <a:t>4 / 5</a:t>
+            </a:r>
+          </a:p>
+        </p:txBody>
+      </p:sp>
+      <p:sp>
+        <p:nvSpPr>
+          <p:cNvPr id="6" name="Title"/>
+          <p:cNvSpPr txBox="1"/>
+          <p:nvPr/>
+        </p:nvSpPr>
+        <p:spPr>
+          <a:xfrm>
+            <a:off x="685800" y="700000"/>
+            <a:ext cx="10820400" cy="1150000"/>
+          </a:xfrm>
+          <a:prstGeom prst="rect">
+            <a:avLst/>
+          </a:prstGeom>
+          <a:noFill/>
+          <a:ln>
+            <a:noFill/>
+          </a:ln>
+        </p:spPr>
+        <p:txBody>
+          <a:bodyPr wrap="square" lIns="182880" tIns="91440" rIns="182880" bIns="91440" anchor="ctr">
             <a:normAutofit/>
           </a:bodyPr>
           <a:lstStyle/>
@@ -1785,77 +2050,36 @@
               </a:spcAft>
             </a:pPr>
             <a:r>
-              <a:rPr lang="en-US" sz="2000">
-                <a:solidFill>
-                  <a:srgbClr val="F4FBFF"/>
-                </a:solidFill>
-              </a:rPr>
-              <a:t>Pilot one recurring workflow with one team and owner. Reuse blueprint logic, but scope each instance to its own permissions and assignment. While Autopilot is private preview, require a stop condition and review before expansion.</a:t>
-            </a:r>
-          </a:p>
-        </p:txBody>
-      </p:sp>
-      <p:sp>
-        <p:nvSpPr>
-          <p:cNvPr id="5" name="Accent rule"/>
-          <p:cNvSpPr/>
-          <p:nvPr/>
-        </p:nvSpPr>
-        <p:spPr>
-          <a:xfrm>
-            <a:off x="548640" y="1800000"/>
-            <a:ext cx="45720" cy="3800000"/>
-          </a:xfrm>
-          <a:prstGeom prst="rect">
-            <a:avLst/>
-          </a:prstGeom>
-          <a:solidFill>
-            <a:srgbClr val="16B8C8"/>
-          </a:solidFill>
-          <a:ln>
-            <a:noFill/>
-          </a:ln>
-        </p:spPr>
-      </p:sp>
-      <p:pic>
-        <p:nvPicPr>
-          <p:cNvPr id="6" name="Asset visual-pilot" descr="A narrow, accountable private-preview pilot with explicit expansion gates. (marp diagram)"/>
-          <p:cNvPicPr>
-            <a:picLocks noChangeAspect="1"/>
-          </p:cNvPicPr>
-          <p:nvPr/>
-        </p:nvPicPr>
-        <p:blipFill>
-          <a:blip r:embed="rIdImage1"/>
-          <a:stretch>
-            <a:fillRect/>
-          </a:stretch>
-        </p:blipFill>
-        <p:spPr>
-          <a:xfrm>
-            <a:off x="5000000" y="2021875"/>
-            <a:ext cx="6500000" cy="3656250"/>
-          </a:xfrm>
-          <a:prstGeom prst="rect">
-            <a:avLst/>
-          </a:prstGeom>
-          <a:ln>
-            <a:solidFill>
-              <a:srgbClr val="D9D9D9"/>
-            </a:solidFill>
-          </a:ln>
-        </p:spPr>
-      </p:pic>
-      <p:sp>
-        <p:nvSpPr>
-          <p:cNvPr id="7" name="Footer"/>
-          <p:cNvSpPr txBox="1"/>
-          <p:nvPr/>
-        </p:nvSpPr>
-        <p:spPr>
-          <a:xfrm>
-            <a:off x="685800" y="6250000"/>
-            <a:ext cx="9400000" cy="420000"/>
+              <a:rPr lang="en-US" sz="2900" b="1">
+                <a:solidFill>
+                  <a:srgbClr val="0B121E"/>
+                </a:solidFill>
+                <a:latin typeface="+mj-lt"/>
+              </a:rPr>
+              <a:t>3.</a:t>
+            </a:r>
+            <a:r>
+              <a:rPr lang="en-US" sz="2900" b="1">
+                <a:solidFill>
+                  <a:srgbClr val="006EC3"/>
+                </a:solidFill>
+                <a:latin typeface="+mj-lt"/>
+              </a:rPr>
+              <a:t> Pilot the role, not the technology</a:t>
+            </a:r>
+          </a:p>
+        </p:txBody>
+      </p:sp>
+      <p:sp>
+        <p:nvSpPr>
+          <p:cNvPr id="7" name="Body"/>
+          <p:cNvSpPr txBox="1"/>
+          <p:nvPr/>
+        </p:nvSpPr>
+        <p:spPr>
+          <a:xfrm>
+            <a:off x="685800" y="1950000"/>
+            <a:ext cx="3900000" cy="3900000"/>
           </a:xfrm>
           <a:prstGeom prst="rect">
             <a:avLst/>
@@ -1880,26 +2104,77 @@
               </a:spcAft>
             </a:pPr>
             <a:r>
-              <a:rPr lang="en-US" sz="1000">
-                <a:solidFill>
-                  <a:srgbClr val="B2BCC4"/>
-                </a:solidFill>
-              </a:rPr>
-              <a:t>Sources: Introducing the new Copilot with Home, Code and Autopilot  ·  What is an autopilot in Microsoft Foundry?</a:t>
-            </a:r>
-          </a:p>
-        </p:txBody>
-      </p:sp>
-      <p:sp>
-        <p:nvSpPr>
-          <p:cNvPr id="8" name="Slide number"/>
-          <p:cNvSpPr txBox="1"/>
-          <p:nvPr/>
-        </p:nvSpPr>
-        <p:spPr>
-          <a:xfrm>
-            <a:off x="10100000" y="6250000"/>
-            <a:ext cx="1400000" cy="420000"/>
+              <a:rPr lang="en-US" sz="2000">
+                <a:solidFill>
+                  <a:srgbClr val="0B121E"/>
+                </a:solidFill>
+              </a:rPr>
+              <a:t>Pilot one recurring workflow with one team and owner. Reuse blueprint logic, but scope each instance to its own permissions and assignment. While Autopilot is private preview, require a stop condition and review before expansion.</a:t>
+            </a:r>
+          </a:p>
+        </p:txBody>
+      </p:sp>
+      <p:sp>
+        <p:nvSpPr>
+          <p:cNvPr id="8" name="Accent rule"/>
+          <p:cNvSpPr/>
+          <p:nvPr/>
+        </p:nvSpPr>
+        <p:spPr>
+          <a:xfrm>
+            <a:off x="548640" y="2000000"/>
+            <a:ext cx="45720" cy="3800000"/>
+          </a:xfrm>
+          <a:prstGeom prst="rect">
+            <a:avLst/>
+          </a:prstGeom>
+          <a:solidFill>
+            <a:srgbClr val="006EC3"/>
+          </a:solidFill>
+          <a:ln>
+            <a:noFill/>
+          </a:ln>
+        </p:spPr>
+      </p:sp>
+      <p:pic>
+        <p:nvPicPr>
+          <p:cNvPr id="9" name="Asset visual-pilot" descr="A narrow, accountable private-preview pilot with explicit expansion gates. (marp diagram)"/>
+          <p:cNvPicPr>
+            <a:picLocks noChangeAspect="1"/>
+          </p:cNvPicPr>
+          <p:nvPr/>
+        </p:nvPicPr>
+        <p:blipFill>
+          <a:blip r:embed="rIdImage1"/>
+          <a:stretch>
+            <a:fillRect/>
+          </a:stretch>
+        </p:blipFill>
+        <p:spPr>
+          <a:xfrm>
+            <a:off x="5000000" y="2221875"/>
+            <a:ext cx="6500000" cy="3656250"/>
+          </a:xfrm>
+          <a:prstGeom prst="rect">
+            <a:avLst/>
+          </a:prstGeom>
+          <a:ln>
+            <a:solidFill>
+              <a:srgbClr val="D9D9D9"/>
+            </a:solidFill>
+          </a:ln>
+        </p:spPr>
+      </p:pic>
+      <p:sp>
+        <p:nvSpPr>
+          <p:cNvPr id="10" name="Footer"/>
+          <p:cNvSpPr txBox="1"/>
+          <p:nvPr/>
+        </p:nvSpPr>
+        <p:spPr>
+          <a:xfrm>
+            <a:off x="685800" y="6250000"/>
+            <a:ext cx="10820400" cy="420000"/>
           </a:xfrm>
           <a:prstGeom prst="rect">
             <a:avLst/>
@@ -1915,14 +2190,21 @@
           </a:bodyPr>
           <a:lstStyle/>
           <a:p>
-            <a:pPr algn="r"/>
+            <a:pPr algn="l">
+              <a:lnSpc>
+                <a:spcPct val="105000"/>
+              </a:lnSpc>
+              <a:spcAft>
+                <a:spcPts val="0"/>
+              </a:spcAft>
+            </a:pPr>
             <a:r>
               <a:rPr lang="en-US" sz="1000">
                 <a:solidFill>
-                  <a:srgbClr val="B2BCC4"/>
-                </a:solidFill>
-              </a:rPr>
-              <a:t>4 / 5</a:t>
+                  <a:srgbClr val="64686E"/>
+                </a:solidFill>
+              </a:rPr>
+              <a:t>Sources: Introducing the new Copilot with Home, Code and Autopilot  ·  What is an autopilot in Microsoft Foundry?</a:t>
             </a:r>
           </a:p>
         </p:txBody>
@@ -1941,7 +2223,7 @@
     <p:bg>
       <p:bgPr>
         <a:solidFill>
-          <a:srgbClr val="071B2D"/>
+          <a:srgbClr val="F4F8FC"/>
         </a:solidFill>
         <a:effectLst/>
       </p:bgPr>
@@ -1955,20 +2237,20 @@
       <p:grpSpPr/>
       <p:sp>
         <p:nvSpPr>
-          <p:cNvPr id="2" name="Accent band"/>
+          <p:cNvPr id="2" name="Brand band"/>
           <p:cNvSpPr/>
           <p:nvPr/>
         </p:nvSpPr>
         <p:spPr>
           <a:xfrm>
             <a:off x="0" y="0"/>
-            <a:ext cx="12192000" cy="91440"/>
+            <a:ext cx="12192000" cy="502920"/>
           </a:xfrm>
           <a:prstGeom prst="rect">
             <a:avLst/>
           </a:prstGeom>
           <a:solidFill>
-            <a:srgbClr val="16B8C8"/>
+            <a:srgbClr val="0E1726"/>
           </a:solidFill>
           <a:ln>
             <a:noFill/>
@@ -1977,14 +2259,36 @@
       </p:sp>
       <p:sp>
         <p:nvSpPr>
-          <p:cNvPr id="3" name="Title"/>
-          <p:cNvSpPr txBox="1"/>
-          <p:nvPr/>
-        </p:nvSpPr>
-        <p:spPr>
-          <a:xfrm>
-            <a:off x="685800" y="420000"/>
-            <a:ext cx="10820400" cy="1000000"/>
+          <p:cNvPr id="3" name="Highlight rule"/>
+          <p:cNvSpPr/>
+          <p:nvPr/>
+        </p:nvSpPr>
+        <p:spPr>
+          <a:xfrm>
+            <a:off x="0" y="502920"/>
+            <a:ext cx="12192000" cy="45720"/>
+          </a:xfrm>
+          <a:prstGeom prst="rect">
+            <a:avLst/>
+          </a:prstGeom>
+          <a:solidFill>
+            <a:srgbClr val="8AC1EB"/>
+          </a:solidFill>
+          <a:ln>
+            <a:noFill/>
+          </a:ln>
+        </p:spPr>
+      </p:sp>
+      <p:sp>
+        <p:nvSpPr>
+          <p:cNvPr id="4" name="Deck kicker"/>
+          <p:cNvSpPr txBox="1"/>
+          <p:nvPr/>
+        </p:nvSpPr>
+        <p:spPr>
+          <a:xfrm>
+            <a:off x="685800" y="0"/>
+            <a:ext cx="8400000" cy="502920"/>
           </a:xfrm>
           <a:prstGeom prst="rect">
             <a:avLst/>
@@ -2009,45 +2313,74 @@
               </a:spcAft>
             </a:pPr>
             <a:r>
-              <a:rPr lang="en-US" sz="2400" b="1">
-                <a:solidFill>
-                  <a:srgbClr val="F4FBFF"/>
-                </a:solidFill>
-              </a:rPr>
-              <a:t>Sources.</a:t>
-            </a:r>
-            <a:r>
-              <a:rPr lang="en-US" sz="2400" b="1">
-                <a:solidFill>
-                  <a:srgbClr val="16B8C8"/>
-                </a:solidFill>
-              </a:rPr>
-              <a:t> Every claim traces to one.</a:t>
-            </a:r>
-          </a:p>
-        </p:txBody>
-      </p:sp>
-      <p:sp>
-        <p:nvSpPr>
-          <p:cNvPr id="4" name="Sources"/>
-          <p:cNvSpPr txBox="1"/>
-          <p:nvPr/>
-        </p:nvSpPr>
-        <p:spPr>
-          <a:xfrm>
-            <a:off x="685800" y="1700000"/>
-            <a:ext cx="10820400" cy="4300000"/>
-          </a:xfrm>
-          <a:prstGeom prst="rect">
-            <a:avLst/>
-          </a:prstGeom>
-          <a:noFill/>
-          <a:ln>
-            <a:noFill/>
-          </a:ln>
-        </p:spPr>
-        <p:txBody>
-          <a:bodyPr wrap="square" lIns="182880" tIns="91440" rIns="182880" bIns="91440" anchor="t">
+              <a:rPr lang="en-US" sz="1100" b="1" cap="all" spc="120">
+                <a:solidFill>
+                  <a:srgbClr val="FFFFFF"/>
+                </a:solidFill>
+              </a:rPr>
+              <a:t>Autopilot Agents</a:t>
+            </a:r>
+          </a:p>
+        </p:txBody>
+      </p:sp>
+      <p:sp>
+        <p:nvSpPr>
+          <p:cNvPr id="5" name="Slide number"/>
+          <p:cNvSpPr txBox="1"/>
+          <p:nvPr/>
+        </p:nvSpPr>
+        <p:spPr>
+          <a:xfrm>
+            <a:off x="9100000" y="0"/>
+            <a:ext cx="2406400" cy="502920"/>
+          </a:xfrm>
+          <a:prstGeom prst="rect">
+            <a:avLst/>
+          </a:prstGeom>
+          <a:noFill/>
+          <a:ln>
+            <a:noFill/>
+          </a:ln>
+        </p:spPr>
+        <p:txBody>
+          <a:bodyPr wrap="square" lIns="182880" tIns="91440" rIns="182880" bIns="91440" anchor="ctr">
+            <a:normAutofit/>
+          </a:bodyPr>
+          <a:lstStyle/>
+          <a:p>
+            <a:pPr algn="r"/>
+            <a:r>
+              <a:rPr lang="en-US" sz="1100" b="1" cap="all" spc="120">
+                <a:solidFill>
+                  <a:srgbClr val="BCBEC2"/>
+                </a:solidFill>
+              </a:rPr>
+              <a:t>5 / 5</a:t>
+            </a:r>
+          </a:p>
+        </p:txBody>
+      </p:sp>
+      <p:sp>
+        <p:nvSpPr>
+          <p:cNvPr id="6" name="Title"/>
+          <p:cNvSpPr txBox="1"/>
+          <p:nvPr/>
+        </p:nvSpPr>
+        <p:spPr>
+          <a:xfrm>
+            <a:off x="685800" y="760000"/>
+            <a:ext cx="10820400" cy="1000000"/>
+          </a:xfrm>
+          <a:prstGeom prst="rect">
+            <a:avLst/>
+          </a:prstGeom>
+          <a:noFill/>
+          <a:ln>
+            <a:noFill/>
+          </a:ln>
+        </p:spPr>
+        <p:txBody>
+          <a:bodyPr wrap="square" lIns="182880" tIns="91440" rIns="182880" bIns="91440" anchor="ctr">
             <a:normAutofit/>
           </a:bodyPr>
           <a:lstStyle/>
@@ -2061,9 +2394,63 @@
               </a:spcAft>
             </a:pPr>
             <a:r>
+              <a:rPr lang="en-US" sz="2400" b="1">
+                <a:solidFill>
+                  <a:srgbClr val="0B121E"/>
+                </a:solidFill>
+                <a:latin typeface="+mj-lt"/>
+              </a:rPr>
+              <a:t>Sources.</a:t>
+            </a:r>
+            <a:r>
+              <a:rPr lang="en-US" sz="2400" b="1">
+                <a:solidFill>
+                  <a:srgbClr val="006EC3"/>
+                </a:solidFill>
+                <a:latin typeface="+mj-lt"/>
+              </a:rPr>
+              <a:t> Every claim traces to one.</a:t>
+            </a:r>
+          </a:p>
+        </p:txBody>
+      </p:sp>
+      <p:sp>
+        <p:nvSpPr>
+          <p:cNvPr id="7" name="Sources"/>
+          <p:cNvSpPr txBox="1"/>
+          <p:nvPr/>
+        </p:nvSpPr>
+        <p:spPr>
+          <a:xfrm>
+            <a:off x="685800" y="1900000"/>
+            <a:ext cx="10820400" cy="4300000"/>
+          </a:xfrm>
+          <a:prstGeom prst="rect">
+            <a:avLst/>
+          </a:prstGeom>
+          <a:noFill/>
+          <a:ln>
+            <a:noFill/>
+          </a:ln>
+        </p:spPr>
+        <p:txBody>
+          <a:bodyPr wrap="square" lIns="182880" tIns="91440" rIns="182880" bIns="91440" anchor="t">
+            <a:normAutofit/>
+          </a:bodyPr>
+          <a:lstStyle/>
+          <a:p>
+            <a:pPr algn="l">
+              <a:lnSpc>
+                <a:spcPct val="105000"/>
+              </a:lnSpc>
+              <a:spcAft>
+                <a:spcPts val="0"/>
+              </a:spcAft>
+            </a:pPr>
+            <a:r>
               <a:rPr lang="en-US" sz="1400" b="1">
                 <a:solidFill>
-                  <a:srgbClr val="F4FBFF"/>
+                  <a:srgbClr val="0B121E"/>
                 </a:solidFill>
               </a:rPr>
               <a:t>Introducing the new Copilot with Home, Code and Autopilot</a:t>
@@ -2071,7 +2458,7 @@
             <a:r>
               <a:rPr lang="en-US" sz="1100">
                 <a:solidFill>
-                  <a:srgbClr val="B2BCC4"/>
+                  <a:srgbClr val="64686E"/>
                 </a:solidFill>
               </a:rPr>
               <a:t>  retrieved 2026-10-06</a:t>
@@ -2089,7 +2476,7 @@
             <a:r>
               <a:rPr lang="en-US" sz="1100">
                 <a:solidFill>
-                  <a:srgbClr val="16B8C8"/>
+                  <a:srgbClr val="006EC3"/>
                 </a:solidFill>
               </a:rPr>
               <a:t>https://blogs.microsoft.com/blog/2026/09/25/introducing-the-new-copilot-with-home-code-and-autopilot/</a:t>
@@ -2107,7 +2494,7 @@
             <a:r>
               <a:rPr lang="en-US" sz="1400" b="1">
                 <a:solidFill>
-                  <a:srgbClr val="F4FBFF"/>
+                  <a:srgbClr val="0B121E"/>
                 </a:solidFill>
               </a:rPr>
               <a:t>What is an autopilot in Microsoft Foundry?</a:t>
@@ -2115,7 +2502,7 @@
             <a:r>
               <a:rPr lang="en-US" sz="1100">
                 <a:solidFill>
-                  <a:srgbClr val="B2BCC4"/>
+                  <a:srgbClr val="64686E"/>
                 </a:solidFill>
               </a:rPr>
               <a:t>  retrieved 2026-10-06</a:t>
@@ -2133,7 +2520,7 @@
             <a:r>
               <a:rPr lang="en-US" sz="1100">
                 <a:solidFill>
-                  <a:srgbClr val="16B8C8"/>
+                  <a:srgbClr val="006EC3"/>
                 </a:solidFill>
               </a:rPr>
               <a:t>https://learn.microsoft.com/en-us/azure/foundry/agents/concepts/autopilot-overview</a:t>
@@ -2143,14 +2530,14 @@
       </p:sp>
       <p:sp>
         <p:nvSpPr>
-          <p:cNvPr id="5" name="Footer"/>
+          <p:cNvPr id="8" name="Footer"/>
           <p:cNvSpPr txBox="1"/>
           <p:nvPr/>
         </p:nvSpPr>
         <p:spPr>
           <a:xfrm>
             <a:off x="685800" y="6250000"/>
-            <a:ext cx="9400000" cy="420000"/>
+            <a:ext cx="10820400" cy="420000"/>
           </a:xfrm>
           <a:prstGeom prst="rect">
             <a:avLst/>
@@ -2177,47 +2564,10 @@
             <a:r>
               <a:rPr lang="en-US" sz="1000">
                 <a:solidFill>
-                  <a:srgbClr val="B2BCC4"/>
-                </a:solidFill>
-              </a:rPr>
-              <a:t>microsoft-autopilot-agents-2026-06-am-michael-kokoro-onnx</a:t>
-            </a:r>
-          </a:p>
-        </p:txBody>
-      </p:sp>
-      <p:sp>
-        <p:nvSpPr>
-          <p:cNvPr id="6" name="Slide number"/>
-          <p:cNvSpPr txBox="1"/>
-          <p:nvPr/>
-        </p:nvSpPr>
-        <p:spPr>
-          <a:xfrm>
-            <a:off x="10100000" y="6250000"/>
-            <a:ext cx="1400000" cy="420000"/>
-          </a:xfrm>
-          <a:prstGeom prst="rect">
-            <a:avLst/>
-          </a:prstGeom>
-          <a:noFill/>
-          <a:ln>
-            <a:noFill/>
-          </a:ln>
-        </p:spPr>
-        <p:txBody>
-          <a:bodyPr wrap="square" lIns="182880" tIns="91440" rIns="182880" bIns="91440" anchor="t">
-            <a:normAutofit/>
-          </a:bodyPr>
-          <a:lstStyle/>
-          <a:p>
-            <a:pPr algn="r"/>
-            <a:r>
-              <a:rPr lang="en-US" sz="1000">
-                <a:solidFill>
-                  <a:srgbClr val="B2BCC4"/>
-                </a:solidFill>
-              </a:rPr>
-              <a:t>5 / 5</a:t>
+                  <a:srgbClr val="64686E"/>
+                </a:solidFill>
+              </a:rPr>
+              <a:t>microsoft-autopilot-agents-2026-07-am-michael-kokoro-onnx</a:t>
             </a:r>
           </a:p>
         </p:txBody>
@@ -2231,59 +2581,59 @@
 </file>
 
 <file path=ppt/theme/theme1.xml><?xml version="1.0" encoding="utf-8"?>
-<a:theme xmlns:a="http://schemas.openxmlformats.org/drawingml/2006/main" name="executive-blue-teal">
+<a:theme xmlns:a="http://schemas.openxmlformats.org/drawingml/2006/main" name="microsoft-autopilot-agents-brand">
   <a:themeElements>
-    <a:clrScheme name="executive-blue-teal">
+    <a:clrScheme name="microsoft-autopilot-agents-brand">
       <a:dk1>
-        <a:srgbClr val="F4FBFF"/>
+        <a:srgbClr val="0B121E"/>
       </a:dk1>
       <a:lt1>
-        <a:srgbClr val="071B2D"/>
+        <a:srgbClr val="F4F8FC"/>
       </a:lt1>
       <a:dk2>
-        <a:srgbClr val="1F1F1F"/>
+        <a:srgbClr val="0E1726"/>
       </a:dk2>
       <a:lt2>
-        <a:srgbClr val="F8F8F8"/>
+        <a:srgbClr val="E6F1F9"/>
       </a:lt2>
       <a:accent1>
-        <a:srgbClr val="16B8C8"/>
+        <a:srgbClr val="006EC3"/>
       </a:accent1>
       <a:accent2>
-        <a:srgbClr val="5B9BD5"/>
+        <a:srgbClr val="8AC1EB"/>
       </a:accent2>
       <a:accent3>
-        <a:srgbClr val="70AD47"/>
+        <a:srgbClr val="006EC3"/>
       </a:accent3>
       <a:accent4>
-        <a:srgbClr val="FFC000"/>
+        <a:srgbClr val="090F19"/>
       </a:accent4>
       <a:accent5>
-        <a:srgbClr val="C00000"/>
+        <a:srgbClr val="64686E"/>
       </a:accent5>
       <a:accent6>
-        <a:srgbClr val="7030A0"/>
+        <a:srgbClr val="B42318"/>
       </a:accent6>
       <a:hlink>
-        <a:srgbClr val="16B8C8"/>
+        <a:srgbClr val="006EC3"/>
       </a:hlink>
       <a:folHlink>
-        <a:srgbClr val="7F7F7F"/>
+        <a:srgbClr val="64686E"/>
       </a:folHlink>
     </a:clrScheme>
-    <a:fontScheme name="executive-blue-teal">
+    <a:fontScheme name="microsoft-autopilot-agents-brand">
       <a:majorFont>
-        <a:latin typeface="Arial"/>
+        <a:latin typeface="Segoe UI Variable Display"/>
         <a:ea typeface=""/>
         <a:cs typeface=""/>
       </a:majorFont>
       <a:minorFont>
-        <a:latin typeface="Arial"/>
+        <a:latin typeface="Segoe UI"/>
         <a:ea typeface=""/>
         <a:cs typeface=""/>
       </a:minorFont>
     </a:fontScheme>
-    <a:fmtScheme name="executive-blue-teal">
+    <a:fmtScheme name="microsoft-autopilot-agents-brand">
       <a:fillStyleLst>
         <a:solidFill>
           <a:schemeClr val="phClr"/>

</xml_diff>

<commit_message>
feat: regenerate microsoft-autopilot-agents with stable Excalidraw strokes
- render four voices on media adapter 13; the diagram no longer boils at 3.75 Hz
- add video and spatial spectrograms and internal/external alignment evidence

🎨 - Generated by Copilot

Co-authored-by: Copilot <223556219+Copilot@users.noreply.github.com>
</commit_message>
<xml_diff>
--- a/projects/microsoft-autopilot-agents/release/outputs/deck.pptx
+++ b/projects/microsoft-autopilot-agents/release/outputs/deck.pptx
@@ -1172,7 +1172,7 @@
                   <a:srgbClr val="64686E"/>
                 </a:solidFill>
               </a:rPr>
-              <a:t>microsoft-autopilot-agents-2026-07-am-michael-kokoro-onnx</a:t>
+              <a:t>microsoft-autopilot-agents-2026-08-am-michael-kokoro-onnx</a:t>
             </a:r>
           </a:p>
         </p:txBody>
@@ -2567,7 +2567,7 @@
                   <a:srgbClr val="64686E"/>
                 </a:solidFill>
               </a:rPr>
-              <a:t>microsoft-autopilot-agents-2026-07-am-michael-kokoro-onnx</a:t>
+              <a:t>microsoft-autopilot-agents-2026-08-am-michael-kokoro-onnx</a:t>
             </a:r>
           </a:p>
         </p:txBody>

</xml_diff>